<commit_message>
Final tweaks in accompanying docs 2
</commit_message>
<xml_diff>
--- a/NovaCorp_CHRO_Deck.pptx
+++ b/NovaCorp_CHRO_Deck.pptx
@@ -233,7 +233,7 @@
           <c:smooth val="0"/>
           <c:extLst>
             <c:ext xmlns:c16="http://schemas.microsoft.com/office/drawing/2014/chart" uri="{C3380CC4-5D6E-409C-BE32-E72D297353CC}">
-              <c16:uniqueId val="{00000000-3AEA-465E-83CA-2766961D4E5F}"/>
+              <c16:uniqueId val="{00000000-9538-44B8-88EC-CF95CF6088CF}"/>
             </c:ext>
           </c:extLst>
         </c:ser>
@@ -328,7 +328,7 @@
           <c:smooth val="0"/>
           <c:extLst>
             <c:ext xmlns:c16="http://schemas.microsoft.com/office/drawing/2014/chart" uri="{C3380CC4-5D6E-409C-BE32-E72D297353CC}">
-              <c16:uniqueId val="{00000001-3AEA-465E-83CA-2766961D4E5F}"/>
+              <c16:uniqueId val="{00000001-9538-44B8-88EC-CF95CF6088CF}"/>
             </c:ext>
           </c:extLst>
         </c:ser>
@@ -597,7 +597,7 @@
           <c:smooth val="0"/>
           <c:extLst>
             <c:ext xmlns:c16="http://schemas.microsoft.com/office/drawing/2014/chart" uri="{C3380CC4-5D6E-409C-BE32-E72D297353CC}">
-              <c16:uniqueId val="{00000000-369A-485A-8998-230032DFE616}"/>
+              <c16:uniqueId val="{00000000-62B6-44B0-A104-480B44A12120}"/>
             </c:ext>
           </c:extLst>
         </c:ser>
@@ -695,7 +695,7 @@
           <c:smooth val="0"/>
           <c:extLst>
             <c:ext xmlns:c16="http://schemas.microsoft.com/office/drawing/2014/chart" uri="{C3380CC4-5D6E-409C-BE32-E72D297353CC}">
-              <c16:uniqueId val="{00000001-369A-485A-8998-230032DFE616}"/>
+              <c16:uniqueId val="{00000001-62B6-44B0-A104-480B44A12120}"/>
             </c:ext>
           </c:extLst>
         </c:ser>
@@ -784,7 +784,7 @@
           <c:smooth val="0"/>
           <c:extLst>
             <c:ext xmlns:c16="http://schemas.microsoft.com/office/drawing/2014/chart" uri="{C3380CC4-5D6E-409C-BE32-E72D297353CC}">
-              <c16:uniqueId val="{00000002-369A-485A-8998-230032DFE616}"/>
+              <c16:uniqueId val="{00000002-62B6-44B0-A104-480B44A12120}"/>
             </c:ext>
           </c:extLst>
         </c:ser>
@@ -885,7 +885,7 @@
           <c:smooth val="0"/>
           <c:extLst>
             <c:ext xmlns:c16="http://schemas.microsoft.com/office/drawing/2014/chart" uri="{C3380CC4-5D6E-409C-BE32-E72D297353CC}">
-              <c16:uniqueId val="{00000003-369A-485A-8998-230032DFE616}"/>
+              <c16:uniqueId val="{00000003-62B6-44B0-A104-480B44A12120}"/>
             </c:ext>
           </c:extLst>
         </c:ser>
@@ -1069,7 +1069,7 @@
     </p:spTree>
     <p:extLst>
       <p:ext uri="{BB962C8B-B14F-4D97-AF65-F5344CB8AC3E}">
-        <p14:creationId xmlns:p14="http://schemas.microsoft.com/office/powerpoint/2010/main" val="3913337697"/>
+        <p14:creationId xmlns:p14="http://schemas.microsoft.com/office/powerpoint/2010/main" val="678826451"/>
       </p:ext>
     </p:extLst>
   </p:cSld>
@@ -3701,7 +3701,7 @@
                 <a:ea typeface="Segoe UI" pitchFamily="34" charset="-122"/>
                 <a:cs typeface="Segoe UI" pitchFamily="34" charset="-120"/>
               </a:rPr>
-              <a:t>$18.6M at stake</a:t>
+              <a:t>$18.6M by month 18</a:t>
             </a:r>
             <a:endParaRPr lang="en-US" sz="950" dirty="0"/>
           </a:p>
@@ -4404,7 +4404,46 @@
       </p:sp>
       <p:sp>
         <p:nvSpPr>
-          <p:cNvPr id="19" name="Shape 17"/>
+          <p:cNvPr id="19" name="Text 17"/>
+          <p:cNvSpPr/>
+          <p:nvPr/>
+        </p:nvSpPr>
+        <p:spPr>
+          <a:xfrm>
+            <a:off x="9720072" y="2752344"/>
+            <a:ext cx="1719072" cy="310896"/>
+          </a:xfrm>
+          <a:prstGeom prst="rect">
+            <a:avLst/>
+          </a:prstGeom>
+          <a:noFill/>
+          <a:ln/>
+        </p:spPr>
+        <p:txBody>
+          <a:bodyPr wrap="square" lIns="0" tIns="0" rIns="0" bIns="0" rtlCol="0" anchor="ctr"/>
+          <a:lstStyle/>
+          <a:p>
+            <a:pPr marL="0" indent="0">
+              <a:buNone/>
+            </a:pPr>
+            <a:r>
+              <a:rPr lang="en-US" sz="900" dirty="0">
+                <a:solidFill>
+                  <a:srgbClr val="8A8781"/>
+                </a:solidFill>
+                <a:latin typeface="Segoe UI" pitchFamily="34" charset="0"/>
+                <a:ea typeface="Segoe UI" pitchFamily="34" charset="-122"/>
+                <a:cs typeface="Segoe UI" pitchFamily="34" charset="-120"/>
+              </a:rPr>
+              <a:t>over two years</a:t>
+            </a:r>
+            <a:endParaRPr lang="en-US" sz="900" dirty="0"/>
+          </a:p>
+        </p:txBody>
+      </p:sp>
+      <p:sp>
+        <p:nvSpPr>
+          <p:cNvPr id="20" name="Shape 18"/>
           <p:cNvSpPr/>
           <p:nvPr/>
         </p:nvSpPr>
@@ -4438,7 +4477,7 @@
       </p:sp>
       <p:sp>
         <p:nvSpPr>
-          <p:cNvPr id="20" name="Text 18"/>
+          <p:cNvPr id="21" name="Text 19"/>
           <p:cNvSpPr/>
           <p:nvPr/>
         </p:nvSpPr>
@@ -4477,7 +4516,7 @@
       </p:sp>
       <p:sp>
         <p:nvSpPr>
-          <p:cNvPr id="21" name="Text 19"/>
+          <p:cNvPr id="22" name="Text 20"/>
           <p:cNvSpPr/>
           <p:nvPr/>
         </p:nvSpPr>
@@ -4541,7 +4580,7 @@
       </p:sp>
       <p:sp>
         <p:nvSpPr>
-          <p:cNvPr id="22" name="Shape 20"/>
+          <p:cNvPr id="23" name="Shape 21"/>
           <p:cNvSpPr/>
           <p:nvPr/>
         </p:nvSpPr>
@@ -4575,7 +4614,7 @@
       </p:sp>
       <p:sp>
         <p:nvSpPr>
-          <p:cNvPr id="23" name="Text 21"/>
+          <p:cNvPr id="24" name="Text 22"/>
           <p:cNvSpPr/>
           <p:nvPr/>
         </p:nvSpPr>
@@ -4614,7 +4653,7 @@
       </p:sp>
       <p:sp>
         <p:nvSpPr>
-          <p:cNvPr id="24" name="Text 22"/>
+          <p:cNvPr id="25" name="Text 23"/>
           <p:cNvSpPr/>
           <p:nvPr/>
         </p:nvSpPr>
@@ -4678,7 +4717,7 @@
       </p:sp>
       <p:sp>
         <p:nvSpPr>
-          <p:cNvPr id="25" name="Shape 23"/>
+          <p:cNvPr id="26" name="Shape 24"/>
           <p:cNvSpPr/>
           <p:nvPr/>
         </p:nvSpPr>
@@ -4705,7 +4744,7 @@
       </p:sp>
       <p:sp>
         <p:nvSpPr>
-          <p:cNvPr id="26" name="Text 24"/>
+          <p:cNvPr id="27" name="Text 25"/>
           <p:cNvSpPr/>
           <p:nvPr/>
         </p:nvSpPr>
@@ -4744,7 +4783,7 @@
       </p:sp>
       <p:sp>
         <p:nvSpPr>
-          <p:cNvPr id="27" name="Shape 25"/>
+          <p:cNvPr id="28" name="Shape 26"/>
           <p:cNvSpPr/>
           <p:nvPr/>
         </p:nvSpPr>
@@ -4771,7 +4810,7 @@
       </p:sp>
       <p:sp>
         <p:nvSpPr>
-          <p:cNvPr id="28" name="Text 26"/>
+          <p:cNvPr id="29" name="Text 27"/>
           <p:cNvSpPr/>
           <p:nvPr/>
         </p:nvSpPr>
@@ -5600,7 +5639,7 @@
                 <a:ea typeface="Segoe UI" pitchFamily="34" charset="-122"/>
                 <a:cs typeface="Segoe UI" pitchFamily="34" charset="-120"/>
               </a:rPr>
-              <a:t>correctly scoped</a:t>
+              <a:t>over two years</a:t>
             </a:r>
             <a:endParaRPr lang="en-US" sz="850" dirty="0"/>
           </a:p>
@@ -5895,7 +5934,7 @@
                 <a:ea typeface="Segoe UI" pitchFamily="34" charset="-122"/>
                 <a:cs typeface="Segoe UI" pitchFamily="34" charset="-120"/>
               </a:rPr>
-              <a:t>between the two paths</a:t>
+              <a:t>the gap by month 18</a:t>
             </a:r>
             <a:endParaRPr lang="en-US" sz="850" dirty="0"/>
           </a:p>
@@ -8254,6 +8293,45 @@
         </p:nvSpPr>
         <p:spPr>
           <a:xfrm>
+            <a:off x="548640" y="4828032"/>
+            <a:ext cx="11091672" cy="237744"/>
+          </a:xfrm>
+          <a:prstGeom prst="rect">
+            <a:avLst/>
+          </a:prstGeom>
+          <a:noFill/>
+          <a:ln/>
+        </p:spPr>
+        <p:txBody>
+          <a:bodyPr wrap="square" lIns="0" tIns="0" rIns="0" bIns="0" rtlCol="0" anchor="ctr"/>
+          <a:lstStyle/>
+          <a:p>
+            <a:pPr marL="0" indent="0">
+              <a:buNone/>
+            </a:pPr>
+            <a:r>
+              <a:rPr lang="en-US" sz="850" i="1" dirty="0">
+                <a:solidFill>
+                  <a:srgbClr val="8A8781"/>
+                </a:solidFill>
+                <a:latin typeface="Segoe UI" pitchFamily="34" charset="0"/>
+                <a:ea typeface="Segoe UI" pitchFamily="34" charset="-122"/>
+                <a:cs typeface="Segoe UI" pitchFamily="34" charset="-120"/>
+              </a:rPr>
+              <a:t>The $64.5M spans the two years analysed; the $18.6M is Entity_C's gap by month 18. Every other figure is annual.</a:t>
+            </a:r>
+            <a:endParaRPr lang="en-US" sz="850" dirty="0"/>
+          </a:p>
+        </p:txBody>
+      </p:sp>
+      <p:sp>
+        <p:nvSpPr>
+          <p:cNvPr id="42" name="Text 40"/>
+          <p:cNvSpPr/>
+          <p:nvPr/>
+        </p:nvSpPr>
+        <p:spPr>
+          <a:xfrm>
             <a:off x="548640" y="5138928"/>
             <a:ext cx="3657600" cy="219456"/>
           </a:xfrm>
@@ -8287,7 +8365,7 @@
       </p:sp>
       <p:sp>
         <p:nvSpPr>
-          <p:cNvPr id="42" name="Shape 40"/>
+          <p:cNvPr id="43" name="Shape 41"/>
           <p:cNvSpPr/>
           <p:nvPr/>
         </p:nvSpPr>
@@ -8314,7 +8392,7 @@
       </p:sp>
       <p:sp>
         <p:nvSpPr>
-          <p:cNvPr id="43" name="Text 41"/>
+          <p:cNvPr id="44" name="Text 42"/>
           <p:cNvSpPr/>
           <p:nvPr/>
         </p:nvSpPr>
@@ -8353,7 +8431,7 @@
       </p:sp>
       <p:sp>
         <p:nvSpPr>
-          <p:cNvPr id="44" name="Text 42"/>
+          <p:cNvPr id="45" name="Text 43"/>
           <p:cNvSpPr/>
           <p:nvPr/>
         </p:nvSpPr>
@@ -8392,7 +8470,7 @@
       </p:sp>
       <p:sp>
         <p:nvSpPr>
-          <p:cNvPr id="45" name="Text 43"/>
+          <p:cNvPr id="46" name="Text 44"/>
           <p:cNvSpPr/>
           <p:nvPr/>
         </p:nvSpPr>
@@ -8431,7 +8509,7 @@
       </p:sp>
       <p:sp>
         <p:nvSpPr>
-          <p:cNvPr id="46" name="Text 44"/>
+          <p:cNvPr id="47" name="Text 45"/>
           <p:cNvSpPr/>
           <p:nvPr/>
         </p:nvSpPr>
@@ -8470,7 +8548,7 @@
       </p:sp>
       <p:sp>
         <p:nvSpPr>
-          <p:cNvPr id="47" name="Text 45"/>
+          <p:cNvPr id="48" name="Text 46"/>
           <p:cNvSpPr/>
           <p:nvPr/>
         </p:nvSpPr>
@@ -8509,7 +8587,7 @@
       </p:sp>
       <p:sp>
         <p:nvSpPr>
-          <p:cNvPr id="48" name="Shape 46"/>
+          <p:cNvPr id="49" name="Shape 47"/>
           <p:cNvSpPr/>
           <p:nvPr/>
         </p:nvSpPr>
@@ -8536,7 +8614,7 @@
       </p:sp>
       <p:sp>
         <p:nvSpPr>
-          <p:cNvPr id="49" name="Shape 47"/>
+          <p:cNvPr id="50" name="Shape 48"/>
           <p:cNvSpPr/>
           <p:nvPr/>
         </p:nvSpPr>
@@ -8563,7 +8641,7 @@
       </p:sp>
       <p:sp>
         <p:nvSpPr>
-          <p:cNvPr id="50" name="Text 48"/>
+          <p:cNvPr id="51" name="Text 49"/>
           <p:cNvSpPr/>
           <p:nvPr/>
         </p:nvSpPr>
@@ -8602,7 +8680,7 @@
       </p:sp>
       <p:sp>
         <p:nvSpPr>
-          <p:cNvPr id="51" name="Shape 49"/>
+          <p:cNvPr id="52" name="Shape 50"/>
           <p:cNvSpPr/>
           <p:nvPr/>
         </p:nvSpPr>
@@ -8629,7 +8707,7 @@
       </p:sp>
       <p:sp>
         <p:nvSpPr>
-          <p:cNvPr id="52" name="Shape 50"/>
+          <p:cNvPr id="53" name="Shape 51"/>
           <p:cNvSpPr/>
           <p:nvPr/>
         </p:nvSpPr>
@@ -8656,7 +8734,7 @@
       </p:sp>
       <p:sp>
         <p:nvSpPr>
-          <p:cNvPr id="53" name="Text 51"/>
+          <p:cNvPr id="54" name="Text 52"/>
           <p:cNvSpPr/>
           <p:nvPr/>
         </p:nvSpPr>
@@ -8695,7 +8773,7 @@
       </p:sp>
       <p:sp>
         <p:nvSpPr>
-          <p:cNvPr id="54" name="Shape 52"/>
+          <p:cNvPr id="55" name="Shape 53"/>
           <p:cNvSpPr/>
           <p:nvPr/>
         </p:nvSpPr>
@@ -8722,7 +8800,7 @@
       </p:sp>
       <p:sp>
         <p:nvSpPr>
-          <p:cNvPr id="55" name="Shape 53"/>
+          <p:cNvPr id="56" name="Shape 54"/>
           <p:cNvSpPr/>
           <p:nvPr/>
         </p:nvSpPr>
@@ -8749,7 +8827,7 @@
       </p:sp>
       <p:sp>
         <p:nvSpPr>
-          <p:cNvPr id="56" name="Text 54"/>
+          <p:cNvPr id="57" name="Text 55"/>
           <p:cNvSpPr/>
           <p:nvPr/>
         </p:nvSpPr>
@@ -8788,7 +8866,7 @@
       </p:sp>
       <p:sp>
         <p:nvSpPr>
-          <p:cNvPr id="57" name="Shape 55"/>
+          <p:cNvPr id="58" name="Shape 56"/>
           <p:cNvSpPr/>
           <p:nvPr/>
         </p:nvSpPr>
@@ -8815,7 +8893,7 @@
       </p:sp>
       <p:sp>
         <p:nvSpPr>
-          <p:cNvPr id="58" name="Shape 56"/>
+          <p:cNvPr id="59" name="Shape 57"/>
           <p:cNvSpPr/>
           <p:nvPr/>
         </p:nvSpPr>
@@ -8842,7 +8920,7 @@
       </p:sp>
       <p:sp>
         <p:nvSpPr>
-          <p:cNvPr id="59" name="Text 57"/>
+          <p:cNvPr id="60" name="Text 58"/>
           <p:cNvSpPr/>
           <p:nvPr/>
         </p:nvSpPr>
@@ -8881,7 +8959,7 @@
       </p:sp>
       <p:sp>
         <p:nvSpPr>
-          <p:cNvPr id="60" name="Shape 58"/>
+          <p:cNvPr id="61" name="Shape 59"/>
           <p:cNvSpPr/>
           <p:nvPr/>
         </p:nvSpPr>
@@ -8908,7 +8986,7 @@
       </p:sp>
       <p:sp>
         <p:nvSpPr>
-          <p:cNvPr id="61" name="Shape 59"/>
+          <p:cNvPr id="62" name="Shape 60"/>
           <p:cNvSpPr/>
           <p:nvPr/>
         </p:nvSpPr>
@@ -8935,7 +9013,7 @@
       </p:sp>
       <p:sp>
         <p:nvSpPr>
-          <p:cNvPr id="62" name="Text 60"/>
+          <p:cNvPr id="63" name="Text 61"/>
           <p:cNvSpPr/>
           <p:nvPr/>
         </p:nvSpPr>
@@ -8974,7 +9052,7 @@
       </p:sp>
       <p:sp>
         <p:nvSpPr>
-          <p:cNvPr id="63" name="Text 61"/>
+          <p:cNvPr id="64" name="Text 62"/>
           <p:cNvSpPr/>
           <p:nvPr/>
         </p:nvSpPr>
@@ -23148,7 +23226,7 @@
                 <a:ea typeface="Segoe UI" pitchFamily="34" charset="-122"/>
                 <a:cs typeface="Segoe UI" pitchFamily="34" charset="-120"/>
               </a:rPr>
-              <a:t>the window is still open</a:t>
+              <a:t>by month 18, window still open</a:t>
             </a:r>
             <a:endParaRPr lang="en-US" sz="900" dirty="0"/>
           </a:p>

</xml_diff>